<commit_message>
feat(motifs): SmartArt-like originals from Infograpify structure
Introduce a motif catalog (not Office SmartArt, not React UI libs):
owned geometry derived from license-safe reference analysis.

- motifs/catalog.json + motif.render_motif builders
- split_hero, card_row, step_rail, kpi_hero, stair_ascent,
  check_stack, tile_row
- Recipes thin-wrap motifs; docs/motifs.md
- Rebuild best/intro demo on motif path (issues 0)
</commit_message>
<xml_diff>
--- a/demo/designmd-pptx-best-v2.1.2.pptx
+++ b/demo/designmd-pptx-best-v2.1.2.pptx
@@ -5,16 +5,16 @@
     <p:sldMasterId xmlns:r="http://schemas.openxmlformats.org/officeDocument/2006/relationships" id="2147483648" r:id="rId1"/>
   </p:sldMasterIdLst>
   <p:sldIdLst>
-    <p:sldId id="256" r:id="R269e527a49884e5c"/>
-    <p:sldId id="257" r:id="R2b22566404564b19"/>
-    <p:sldId id="258" r:id="R962bf375e0a946b7"/>
-    <p:sldId id="259" r:id="R025b11492b314df4"/>
-    <p:sldId id="260" r:id="R7758b82bf54f4e1b"/>
-    <p:sldId id="261" r:id="R8dc64986fcda428b"/>
-    <p:sldId id="262" r:id="Rb64beeff4547457a"/>
-    <p:sldId id="263" r:id="R5ac571f2bc624a7b"/>
-    <p:sldId id="264" r:id="R0a81eeb369bc4425"/>
-    <p:sldId id="265" r:id="Rc53d8e01c0cd422d"/>
+    <p:sldId id="256" r:id="R6b46372f504b4d80"/>
+    <p:sldId id="257" r:id="R997e9c6f95ce4c46"/>
+    <p:sldId id="258" r:id="R684bcc2dfca94c9c"/>
+    <p:sldId id="259" r:id="R0d5be0d5002f4f1d"/>
+    <p:sldId id="260" r:id="R986857ca3c254c61"/>
+    <p:sldId id="261" r:id="R6dca5c91185a48a9"/>
+    <p:sldId id="262" r:id="Rc85c0cafdf3745db"/>
+    <p:sldId id="263" r:id="R5aac87b4b07148c9"/>
+    <p:sldId id="264" r:id="R4be03f64042e4ea7"/>
+    <p:sldId id="265" r:id="Rd3765a694baa4025"/>
   </p:sldIdLst>
   <p:sldSz cx="12192000" cy="6858000"/>
   <p:notesSz cx="6858000" cy="9144000"/>
@@ -219,7 +219,7 @@
           <a:p xmlns:a="http://schemas.openxmlformats.org/drawingml/2006/main">
             <a:r>
               <a:rPr lang="en-US"/>
-              <a:t>Pillars are non-negotiable investments, not initiatives.</a:t>
+              <a:t>Three cards max on a hero slide; cut copy first.</a:t>
             </a:r>
           </a:p>
         </p:txBody>
@@ -271,7 +271,7 @@
           <a:p xmlns:a="http://schemas.openxmlformats.org/drawingml/2006/main">
             <a:r>
               <a:rPr lang="en-US"/>
-              <a:t>Mission is timeless; vision is dated and measurable.</a:t>
+              <a:t>Pillars are non-negotiable investments, not initiatives.</a:t>
             </a:r>
           </a:p>
         </p:txBody>
@@ -323,7 +323,7 @@
           <a:p xmlns:a="http://schemas.openxmlformats.org/drawingml/2006/main">
             <a:r>
               <a:rPr lang="en-US"/>
-              <a:t>You cannot skip a stair — name the exit criteria per step.</a:t>
+              <a:t>Mission is timeless; vision is dated and measurable.</a:t>
             </a:r>
           </a:p>
         </p:txBody>
@@ -334,6 +334,58 @@
 </file>
 
 <file path=ppt/notesSlides/notesSlide7.xml><?xml version="1.0" encoding="utf-8"?>
+<p:notes xmlns:p="http://schemas.openxmlformats.org/presentationml/2006/main">
+  <p:cSld>
+    <p:spTree>
+      <p:nvGrpSpPr>
+        <p:cNvPr id="1" name=""/>
+        <p:cNvGrpSpPr/>
+        <p:nvPr/>
+      </p:nvGrpSpPr>
+      <p:grpSpPr>
+        <a:xfrm xmlns:a="http://schemas.openxmlformats.org/drawingml/2006/main"/>
+      </p:grpSpPr>
+      <p:sp>
+        <p:nvSpPr>
+          <p:cNvPr id="2" name="Slide Image Placeholder 1"/>
+          <p:cNvSpPr/>
+          <p:nvPr>
+            <p:ph type="sldImg" idx="0"/>
+          </p:nvPr>
+        </p:nvSpPr>
+        <p:spPr/>
+        <p:txBody>
+          <a:bodyPr xmlns:a="http://schemas.openxmlformats.org/drawingml/2006/main"/>
+          <a:lstStyle xmlns:a="http://schemas.openxmlformats.org/drawingml/2006/main"/>
+          <a:p xmlns:a="http://schemas.openxmlformats.org/drawingml/2006/main"/>
+        </p:txBody>
+      </p:sp>
+      <p:sp>
+        <p:nvSpPr>
+          <p:cNvPr id="3" name="Notes Placeholder 2"/>
+          <p:cNvSpPr/>
+          <p:nvPr>
+            <p:ph type="body" idx="1"/>
+          </p:nvPr>
+        </p:nvSpPr>
+        <p:spPr/>
+        <p:txBody>
+          <a:bodyPr xmlns:a="http://schemas.openxmlformats.org/drawingml/2006/main"/>
+          <a:lstStyle xmlns:a="http://schemas.openxmlformats.org/drawingml/2006/main"/>
+          <a:p xmlns:a="http://schemas.openxmlformats.org/drawingml/2006/main">
+            <a:r>
+              <a:rPr lang="en-US"/>
+              <a:t>You cannot skip a stair — name the exit criteria.</a:t>
+            </a:r>
+          </a:p>
+        </p:txBody>
+      </p:sp>
+    </p:spTree>
+  </p:cSld>
+</p:notes>
+</file>
+
+<file path=ppt/notesSlides/notesSlide8.xml><?xml version="1.0" encoding="utf-8"?>
 <p:notes xmlns:p="http://schemas.openxmlformats.org/presentationml/2006/main">
   <p:cSld>
     <p:spTree>

</xml_diff>

<commit_message>
feat(motifs): full 14 goldens + org_cascade / chevron_flow
Add org hierarchy and chevron process motifs (StageMetrics chrome), wire
org_tree and chevron_process recipes, and regenerate golden one-pagers for
the entire catalog (14 sequence + contact sheets). Bump demo KPI count.
</commit_message>
<xml_diff>
--- a/demo/designmd-pptx-best-v2.1.2.pptx
+++ b/demo/designmd-pptx-best-v2.1.2.pptx
@@ -5,18 +5,18 @@
     <p:sldMasterId xmlns:r="http://schemas.openxmlformats.org/officeDocument/2006/relationships" id="2147483648" r:id="rId1"/>
   </p:sldMasterIdLst>
   <p:sldIdLst>
-    <p:sldId id="256" r:id="R8de47c23f4cd437f"/>
-    <p:sldId id="257" r:id="R4753ea1be7bf4830"/>
-    <p:sldId id="258" r:id="R2c742daa40674f2c"/>
-    <p:sldId id="259" r:id="R9c2f86182d6a4502"/>
-    <p:sldId id="260" r:id="R6f2d2bc561644c29"/>
-    <p:sldId id="261" r:id="R37934be00e2d4dbf"/>
-    <p:sldId id="262" r:id="R1e8d55fed5d54793"/>
-    <p:sldId id="263" r:id="Rc198e7811a8c44cf"/>
-    <p:sldId id="264" r:id="Ref0423f086cd4876"/>
-    <p:sldId id="265" r:id="Rc2541192e8844696"/>
-    <p:sldId id="266" r:id="R9bb0e96e7eee452b"/>
-    <p:sldId id="267" r:id="R13e9eff22d524f78"/>
+    <p:sldId id="256" r:id="Rd7c09b62344443ac"/>
+    <p:sldId id="257" r:id="R15c8823dac2546cf"/>
+    <p:sldId id="258" r:id="R818f59b6af904f4c"/>
+    <p:sldId id="259" r:id="Rc5cf20725dfa4b2e"/>
+    <p:sldId id="260" r:id="R1ef12b35d6ff446b"/>
+    <p:sldId id="261" r:id="R5561d25440e24b7c"/>
+    <p:sldId id="262" r:id="Rb1bffeb0e84e4c75"/>
+    <p:sldId id="263" r:id="Ra346319e9b7b4e99"/>
+    <p:sldId id="264" r:id="R05e1212d95c14571"/>
+    <p:sldId id="265" r:id="R2809a799792d494b"/>
+    <p:sldId id="266" r:id="R93929c4b0b5c4d8c"/>
+    <p:sldId id="267" r:id="R3568af78feef4cff"/>
   </p:sldIdLst>
   <p:sldSz cx="12192000" cy="6858000"/>
   <p:notesSz cx="6858000" cy="9144000"/>
@@ -2564,7 +2564,7 @@
                 <a:latin typeface="Arial"/>
                 <a:ea typeface="Arial"/>
               </a:rPr>
-              <a:t>12</a:t>
+              <a:t>14</a:t>
             </a:r>
           </a:p>
         </p:txBody>
@@ -2632,7 +2632,7 @@
                 <a:latin typeface="Arial"/>
                 <a:ea typeface="Arial"/>
               </a:rPr>
-              <a:t>v1</a:t>
+              <a:t>v1.2</a:t>
             </a:r>
           </a:p>
         </p:txBody>

</xml_diff>

<commit_message>
feat(motifs): collapse 400 Infograpify decks into full structural catalog
Map all 75 recipes to ~66 owned motifs (coverage.py + structural pack +
recipe adapters). Catalog schema 2 records family collapse; goldens for
every motif id. Not 1:1 vendor clones — license-safe structure only.
</commit_message>
<xml_diff>
--- a/demo/designmd-pptx-best-v2.1.2.pptx
+++ b/demo/designmd-pptx-best-v2.1.2.pptx
@@ -5,18 +5,18 @@
     <p:sldMasterId xmlns:r="http://schemas.openxmlformats.org/officeDocument/2006/relationships" id="2147483648" r:id="rId1"/>
   </p:sldMasterIdLst>
   <p:sldIdLst>
-    <p:sldId id="256" r:id="Rd7c09b62344443ac"/>
-    <p:sldId id="257" r:id="R15c8823dac2546cf"/>
-    <p:sldId id="258" r:id="R818f59b6af904f4c"/>
-    <p:sldId id="259" r:id="Rc5cf20725dfa4b2e"/>
-    <p:sldId id="260" r:id="R1ef12b35d6ff446b"/>
-    <p:sldId id="261" r:id="R5561d25440e24b7c"/>
-    <p:sldId id="262" r:id="Rb1bffeb0e84e4c75"/>
-    <p:sldId id="263" r:id="Ra346319e9b7b4e99"/>
-    <p:sldId id="264" r:id="R05e1212d95c14571"/>
-    <p:sldId id="265" r:id="R2809a799792d494b"/>
-    <p:sldId id="266" r:id="R93929c4b0b5c4d8c"/>
-    <p:sldId id="267" r:id="R3568af78feef4cff"/>
+    <p:sldId id="256" r:id="R3d13275379ab46c2"/>
+    <p:sldId id="257" r:id="R8f2cc21d29534b24"/>
+    <p:sldId id="258" r:id="Ra0d112ed1aea419d"/>
+    <p:sldId id="259" r:id="R5cff4d17a75146ee"/>
+    <p:sldId id="260" r:id="R5e3f7139cb834f33"/>
+    <p:sldId id="261" r:id="R034fc5b6262b4725"/>
+    <p:sldId id="262" r:id="R525a84c3569643bb"/>
+    <p:sldId id="263" r:id="R4010c85c50264c85"/>
+    <p:sldId id="264" r:id="Rd31a080058c94fd6"/>
+    <p:sldId id="265" r:id="R3a955052a8bf4201"/>
+    <p:sldId id="266" r:id="R5c14b74e64874c60"/>
+    <p:sldId id="267" r:id="R2909cd00091c47ef"/>
   </p:sldIdLst>
   <p:sldSz cx="12192000" cy="6858000"/>
   <p:notesSz cx="6858000" cy="9144000"/>
@@ -2564,7 +2564,7 @@
                 <a:latin typeface="Arial"/>
                 <a:ea typeface="Arial"/>
               </a:rPr>
-              <a:t>14</a:t>
+              <a:t>66</a:t>
             </a:r>
           </a:p>
         </p:txBody>
@@ -2632,7 +2632,7 @@
                 <a:latin typeface="Arial"/>
                 <a:ea typeface="Arial"/>
               </a:rPr>
-              <a:t>v1.2</a:t>
+              <a:t>v2</a:t>
             </a:r>
           </a:p>
         </p:txBody>

</xml_diff>